<commit_message>
Fix architecture diagram title overlap; add authors (Avi Dhandhania 25BCE1207, Shivesh Kumar 25BCE1067)
</commit_message>
<xml_diff>
--- a/presentation/DA1_Presentation.pptx
+++ b/presentation/DA1_Presentation.pptx
@@ -3213,6 +3213,41 @@
           </a:p>
         </p:txBody>
       </p:sp>
+      <p:sp>
+        <p:nvSpPr>
+          <p:cNvPr id="5" name="TextBox 4"/>
+          <p:cNvSpPr txBox="1"/>
+          <p:nvPr/>
+        </p:nvSpPr>
+        <p:spPr>
+          <a:xfrm>
+            <a:off x="731520" y="5394960"/>
+            <a:ext cx="10698480" cy="457200"/>
+          </a:xfrm>
+          <a:prstGeom prst="rect">
+            <a:avLst/>
+          </a:prstGeom>
+          <a:noFill/>
+        </p:spPr>
+        <p:txBody>
+          <a:bodyPr wrap="square">
+            <a:spAutoFit/>
+          </a:bodyPr>
+          <a:lstStyle/>
+          <a:p>
+            <a:pPr algn="ctr"/>
+            <a:r>
+              <a:rPr sz="1700" b="1" i="0">
+                <a:solidFill>
+                  <a:srgbClr val="FFFFFF"/>
+                </a:solidFill>
+                <a:latin typeface="Calibri"/>
+              </a:rPr>
+              <a:t>Avi Dhandhania (25BCE1207)   •   Shivesh Kumar (25BCE1067)</a:t>
+            </a:r>
+          </a:p>
+        </p:txBody>
+      </p:sp>
     </p:spTree>
   </p:cSld>
   <p:clrMapOvr>
@@ -5274,8 +5309,8 @@
         </p:blipFill>
         <p:spPr>
           <a:xfrm>
-            <a:off x="2358237" y="1097280"/>
-            <a:ext cx="7475219" cy="5120640"/>
+            <a:off x="2581788" y="1097280"/>
+            <a:ext cx="7028118" cy="5120640"/>
           </a:xfrm>
           <a:prstGeom prst="rect">
             <a:avLst/>

</xml_diff>